<commit_message>
deck: make cross-references self-contained (topic names, §N pills) for live presentation (r177)
</commit_message>
<xml_diff>
--- a/presentation/cpp-statelessness-compendium.pptx
+++ b/presentation/cpp-statelessness-compendium.pptx
@@ -1078,7 +1078,7 @@
           <a:p>
             <a:r>
               <a:rPr sz="1200"/>
-              <a:t>This is the counterexample the doc dwells on because it's the one mistake PMR makes easy. The arena is on the stack or in the RequestContext; if you hand a pmr::string built in it back to a caller that outlives the request, you've got a use-after-free. ASan catches it on the first run — which is why the dev profile in Doc 11 wires ASan in by default.</a:t>
+              <a:t>This is the counterexample the doc dwells on because it's the one mistake PMR makes easy. The arena is on the stack or in the RequestContext; if you hand a pmr::string built in it back to a caller that outlives the request, you've got a use-after-free. ASan catches it on the first run — which is why the dev profile wires ASan in by default.</a:t>
             </a:r>
           </a:p>
         </p:txBody>
@@ -1581,7 +1581,7 @@
           <a:p>
             <a:r>
               <a:rPr sz="1200"/>
-              <a:t>The recurring theme: the container's resource limits are the sizing budget for process-scoped state. An unbounded in-process cache that's fine on a 256 GB box becomes a slow OOMKill under a 512 MB memory cgroup. Everything process-scoped should be bounded and sized against the cgroup, which means reading the cgroup — the helper we ship in Doc 11.</a:t>
+              <a:t>The recurring theme: the container's resource limits are the sizing budget for process-scoped state. An unbounded in-process cache that's fine on a 256 GB box becomes a slow OOMKill under a 512 MB memory cgroup. Everything process-scoped should be bounded and sized against the cgroup, which means reading the cgroup — the helper we ship in the build-tooling section.</a:t>
             </a:r>
           </a:p>
         </p:txBody>
@@ -2149,7 +2149,7 @@
           <a:p>
             <a:r>
               <a:rPr sz="1200"/>
-              <a:t>This compendium is the architectural spine under the performance talk. The thesis of Doc 1 sets the vocabulary for everything that follows: statelessness isn't something you can read off a source file. The same C++ binary can be stateless or stateful depending on what state it holds and where. What makes a service 'stateless' is a property the orchestrator relies on — that it can kill, restart, and scale a replica without coordination.</a:t>
+              <a:t>This compendium is the architectural spine under the performance talk. The thesis here sets the vocabulary for everything that follows: statelessness isn't something you can read off a source file. The same C++ binary can be stateless or stateful depending on what state it holds and where. What makes a service 'stateless' is a property the orchestrator relies on — that it can kill, restart, and scale a replica without coordination.</a:t>
             </a:r>
           </a:p>
         </p:txBody>
@@ -2220,7 +2220,7 @@
           <a:p>
             <a:r>
               <a:rPr sz="1200"/>
-              <a:t>std::jthread and std::stop_token are the C++20 tools for clean worker lifecycle. A jthread joins automatically when it goes out of scope, so you can't accidentally leak a thread past main(); and the stop_token gives cooperative cancellation — the worker checks stop_requested() and exits its loop. The shutdown sequence in Doc 9 uses exactly this to drain the outbox relay and other background work.</a:t>
+              <a:t>std::jthread and std::stop_token are the C++20 tools for clean worker lifecycle. A jthread joins automatically when it goes out of scope, so you can't accidentally leak a thread past main(); and the stop_token gives cooperative cancellation — the worker checks stop_requested() and exits its loop. The the health-and-shutdown sequence uses exactly this to drain the outbox relay and other background work.</a:t>
             </a:r>
           </a:p>
         </p:txBody>
@@ -3143,7 +3143,7 @@
           <a:p>
             <a:r>
               <a:rPr sz="1200"/>
-              <a:t>This closes the loop on Doc 1's counterexample. A local in-process cache of authoritative data is the classic statelessness violation: two replicas hold divergent views, and which answer you get depends on which replica you hit. The fix is to move the cache to deploy-time scope — a shared cache tier — so it's authoritative and consistent across replicas. In-process caching is only safe for data that's immutable or purely derived and cheap to rebuild.</a:t>
+              <a:t>This closes the loop on the earlier cache counterexample. A local in-process cache of authoritative data is the classic statelessness violation: two replicas hold divergent views, and which answer you get depends on which replica you hit. The fix is to move the cache to deploy-time scope — a shared cache tier — so it's authoritative and consistent across replicas. In-process caching is only safe for data that's immutable or purely derived and cheap to rebuild.</a:t>
             </a:r>
           </a:p>
         </p:txBody>
@@ -3711,7 +3711,7 @@
           <a:p>
             <a:r>
               <a:rPr sz="1200"/>
-              <a:t>The three-scope vocabulary is used in every later document, so it's worth fixing now. Request scope is the per-RPC lifetime — RAII makes this concrete (Doc 2). Process scope is the process lifetime — pools, channels, parsed config, owned in main() (Doc 4). Deploy-time scope is everything outside the process — the externalized authoritative state (Doc 7).</a:t>
+              <a:t>The three-scope vocabulary is used in every later document, so it's worth fixing now. Request scope is the per-RPC lifetime — RAII makes this concrete (the RAII section). Process scope is the process lifetime — pools, channels, parsed config, owned in main() (process scope). Deploy-time scope is everything outside the process — the externalized authoritative state (state externalization).</a:t>
             </a:r>
           </a:p>
           <a:p>
@@ -4356,7 +4356,7 @@
           <a:p>
             <a:r>
               <a:rPr sz="1200"/>
-              <a:t>The capstone's main() is twelve steps and every one maps to a prior document — config from Doc 6, CPU budget from Doc 5, pools from Doc 7, the composition root from Doc 4, the staged health flip and signal handling from Doc 9. The shape is the same for any gRPC service in this stack; only the specific subsystems change. That reusability is the payoff of building the patterns in isolation first.</a:t>
+              <a:t>The capstone's main() is twelve steps and every one maps to a prior document — config from 12-factor, CPU budget from threading, pools from externalization, the composition root from process scope, the staged health flip and signal handling from health &amp; shutdown. The shape is the same for any gRPC service in this stack; only the specific subsystems change. That reusability is the payoff of building the patterns in isolation first.</a:t>
             </a:r>
           </a:p>
         </p:txBody>
@@ -5143,7 +5143,7 @@
           <a:p>
             <a:r>
               <a:rPr sz="1200"/>
-              <a:t>The State Architecture Table is the practical heart of Doc 4, introduced here. The exercise is mechanical and clarifying: list every piece of state your service touches, and for each one decide its scope deliberately. Anything authoritative goes to deploy-time scope. Anything that's pure performance infrastructure — pools, caches, channels — is process scope, bounded and owned in main(). Anything per-request is request scope. Get this table right and statelessness falls out.</a:t>
+              <a:t>The State Architecture Table is the practical heart of the process-scope section, introduced here. The exercise is mechanical and clarifying: list every piece of state your service touches, and for each one decide its scope deliberately. Anything authoritative goes to deploy-time scope. Anything that's pure performance infrastructure — pools, caches, channels — is process scope, bounded and owned in main(). Anything per-request is request scope. Get this table right and statelessness falls out.</a:t>
             </a:r>
           </a:p>
         </p:txBody>
@@ -8818,7 +8818,7 @@
                 </a:solidFill>
                 <a:latin typeface="Calibri"/>
               </a:rPr>
-              <a:t>Doc 02</a:t>
+              <a:t>§2</a:t>
             </a:r>
           </a:p>
         </p:txBody>
@@ -9042,7 +9042,7 @@
                 </a:solidFill>
                 <a:latin typeface="Calibri"/>
               </a:rPr>
-              <a:t>•  Locks held across co_await — UB after suspension (Doc 5)</a:t>
+              <a:t>•  Locks held across co_await — UB after suspension (the threading section)</a:t>
             </a:r>
           </a:p>
         </p:txBody>
@@ -9413,7 +9413,7 @@
                 </a:solidFill>
                 <a:latin typeface="Calibri"/>
               </a:rPr>
-              <a:t>Doc 02</a:t>
+              <a:t>§2</a:t>
             </a:r>
           </a:p>
         </p:txBody>
@@ -9805,7 +9805,7 @@
                 </a:solidFill>
                 <a:latin typeface="Calibri"/>
               </a:rPr>
-              <a:t>Doc 02</a:t>
+              <a:t>§2</a:t>
             </a:r>
           </a:p>
         </p:txBody>
@@ -10687,7 +10687,7 @@
                 </a:solidFill>
                 <a:latin typeface="Calibri"/>
               </a:rPr>
-              <a:t>Doc 03</a:t>
+              <a:t>§3</a:t>
             </a:r>
           </a:p>
         </p:txBody>
@@ -11103,7 +11103,7 @@
                 </a:solidFill>
                 <a:latin typeface="Calibri"/>
               </a:rPr>
-              <a:t>Doc 03</a:t>
+              <a:t>§3</a:t>
             </a:r>
           </a:p>
         </p:txBody>
@@ -11295,7 +11295,7 @@
                 </a:solidFill>
                 <a:latin typeface="Calibri"/>
               </a:rPr>
-              <a:t>•  Caught immediately under AddressSanitizer (dev profile, Doc 11)</a:t>
+              <a:t>•  Caught immediately under AddressSanitizer (the dev profile)</a:t>
             </a:r>
           </a:p>
           <a:p>
@@ -11495,7 +11495,7 @@
                 </a:solidFill>
                 <a:latin typeface="Calibri"/>
               </a:rPr>
-              <a:t>Doc 03</a:t>
+              <a:t>§3</a:t>
             </a:r>
           </a:p>
         </p:txBody>
@@ -11903,7 +11903,7 @@
                 </a:solidFill>
                 <a:latin typeface="Calibri"/>
               </a:rPr>
-              <a:t>Doc 03</a:t>
+              <a:t>§3</a:t>
             </a:r>
           </a:p>
         </p:txBody>
@@ -14282,7 +14282,7 @@
                 </a:solidFill>
                 <a:latin typeface="Calibri"/>
               </a:rPr>
-              <a:t>Doc 04</a:t>
+              <a:t>§4</a:t>
             </a:r>
           </a:p>
         </p:txBody>
@@ -14698,7 +14698,7 @@
                 </a:solidFill>
                 <a:latin typeface="Calibri"/>
               </a:rPr>
-              <a:t>Doc 04</a:t>
+              <a:t>§4</a:t>
             </a:r>
           </a:p>
         </p:txBody>
@@ -14890,7 +14890,7 @@
                 </a:solidFill>
                 <a:latin typeface="Calibri"/>
               </a:rPr>
-              <a:t>•  Pool sizes and arena counts scale from the CPU quota (Doc 5)</a:t>
+              <a:t>•  Pool sizes and arena counts scale from the CPU quota (threading)</a:t>
             </a:r>
           </a:p>
           <a:p>
@@ -15090,7 +15090,7 @@
                 </a:solidFill>
                 <a:latin typeface="Calibri"/>
               </a:rPr>
-              <a:t>Doc 04</a:t>
+              <a:t>§4</a:t>
             </a:r>
           </a:p>
         </p:txBody>
@@ -15636,7 +15636,7 @@
                 </a:solidFill>
                 <a:latin typeface="Calibri"/>
               </a:rPr>
-              <a:t>Doc 04</a:t>
+              <a:t>§4</a:t>
             </a:r>
           </a:p>
         </p:txBody>
@@ -16210,7 +16210,7 @@
                 </a:solidFill>
                 <a:latin typeface="Calibri"/>
               </a:rPr>
-              <a:t>Doc 05</a:t>
+              <a:t>§5</a:t>
             </a:r>
           </a:p>
         </p:txBody>
@@ -16626,7 +16626,7 @@
                 </a:solidFill>
                 <a:latin typeface="Calibri"/>
               </a:rPr>
-              <a:t>Doc 05</a:t>
+              <a:t>§5</a:t>
             </a:r>
           </a:p>
         </p:txBody>
@@ -17018,7 +17018,7 @@
                 </a:solidFill>
                 <a:latin typeface="Calibri"/>
               </a:rPr>
-              <a:t>Doc 05</a:t>
+              <a:t>§5</a:t>
             </a:r>
           </a:p>
         </p:txBody>
@@ -17410,7 +17410,7 @@
                 </a:solidFill>
                 <a:latin typeface="Calibri"/>
               </a:rPr>
-              <a:t>Doc 05</a:t>
+              <a:t>§5</a:t>
             </a:r>
           </a:p>
         </p:txBody>
@@ -17968,7 +17968,7 @@
                 </a:solidFill>
                 <a:latin typeface="Calibri"/>
               </a:rPr>
-              <a:t>Doc 05</a:t>
+              <a:t>§5</a:t>
             </a:r>
           </a:p>
         </p:txBody>
@@ -18176,7 +18176,7 @@
                 </a:solidFill>
                 <a:latin typeface="Calibri"/>
               </a:rPr>
-              <a:t>•  Ties directly into the graceful-shutdown sequence (Doc 9)</a:t>
+              <a:t>•  Ties directly into the graceful-shutdown sequence (health &amp; shutdown)</a:t>
             </a:r>
           </a:p>
         </p:txBody>
@@ -18850,7 +18850,7 @@
                 </a:solidFill>
                 <a:latin typeface="Calibri"/>
               </a:rPr>
-              <a:t>Doc 06</a:t>
+              <a:t>§6</a:t>
             </a:r>
           </a:p>
         </p:txBody>
@@ -19282,7 +19282,7 @@
                 </a:solidFill>
                 <a:latin typeface="Calibri"/>
               </a:rPr>
-              <a:t>Doc 06</a:t>
+              <a:t>§6</a:t>
             </a:r>
           </a:p>
         </p:txBody>
@@ -19490,7 +19490,7 @@
                 </a:solidFill>
                 <a:latin typeface="Calibri"/>
               </a:rPr>
-              <a:t>•  Staged startup: NOT_SERVING → warm → SERVING (Doc 9)</a:t>
+              <a:t>•  Staged startup: NOT_SERVING → warm → SERVING (health &amp; shutdown)</a:t>
             </a:r>
           </a:p>
         </p:txBody>
@@ -19674,7 +19674,7 @@
                 </a:solidFill>
                 <a:latin typeface="Calibri"/>
               </a:rPr>
-              <a:t>Doc 06</a:t>
+              <a:t>§6</a:t>
             </a:r>
           </a:p>
         </p:txBody>
@@ -20209,7 +20209,7 @@
                 </a:solidFill>
                 <a:latin typeface="Calibri"/>
               </a:rPr>
-              <a:t>Doc 06</a:t>
+              <a:t>§6</a:t>
             </a:r>
           </a:p>
         </p:txBody>
@@ -20369,7 +20369,7 @@
                 </a:solidFill>
                 <a:latin typeface="Calibri"/>
               </a:rPr>
-              <a:t>•  Logs → stdout, the collector owns persistence (Doc 8)</a:t>
+              <a:t>•  Logs → stdout, the collector owns persistence (ephemeral filesystem)</a:t>
             </a:r>
           </a:p>
           <a:p>
@@ -20385,7 +20385,7 @@
                 </a:solidFill>
                 <a:latin typeface="Calibri"/>
               </a:rPr>
-              <a:t>•  Backing services → attached resources, swappable by config (Doc 7)</a:t>
+              <a:t>•  Backing services → attached resources, swappable by config (state externalization)</a:t>
             </a:r>
           </a:p>
           <a:p>
@@ -20401,7 +20401,7 @@
                 </a:solidFill>
                 <a:latin typeface="Calibri"/>
               </a:rPr>
-              <a:t>•  Build/release/run → the multi-stage Containerfile + a lockfile (Doc 11)</a:t>
+              <a:t>•  Build/release/run → the multi-stage Containerfile + a lockfile (build tooling)</a:t>
             </a:r>
           </a:p>
           <a:p>
@@ -20767,7 +20767,7 @@
                 </a:solidFill>
                 <a:latin typeface="Calibri"/>
               </a:rPr>
-              <a:t>Doc 07</a:t>
+              <a:t>§7</a:t>
             </a:r>
           </a:p>
         </p:txBody>
@@ -21183,7 +21183,7 @@
                 </a:solidFill>
                 <a:latin typeface="Calibri"/>
               </a:rPr>
-              <a:t>Doc 07</a:t>
+              <a:t>§7</a:t>
             </a:r>
           </a:p>
         </p:txBody>
@@ -21575,7 +21575,7 @@
                 </a:solidFill>
                 <a:latin typeface="Calibri"/>
               </a:rPr>
-              <a:t>Doc 01</a:t>
+              <a:t>§1</a:t>
             </a:r>
           </a:p>
         </p:txBody>
@@ -22320,7 +22320,7 @@
                 </a:solidFill>
                 <a:latin typeface="Calibri"/>
               </a:rPr>
-              <a:t>Doc 07</a:t>
+              <a:t>§7</a:t>
             </a:r>
           </a:p>
         </p:txBody>
@@ -22833,7 +22833,7 @@
                 </a:solidFill>
                 <a:latin typeface="Calibri"/>
               </a:rPr>
-              <a:t>Doc 07</a:t>
+              <a:t>§7</a:t>
             </a:r>
           </a:p>
         </p:txBody>
@@ -23225,7 +23225,7 @@
                 </a:solidFill>
                 <a:latin typeface="Calibri"/>
               </a:rPr>
-              <a:t>Doc 07</a:t>
+              <a:t>§7</a:t>
             </a:r>
           </a:p>
         </p:txBody>
@@ -23369,7 +23369,7 @@
                 </a:solidFill>
                 <a:latin typeface="Calibri"/>
               </a:rPr>
-              <a:t>Why the local cache from Doc 1 was the bug</a:t>
+              <a:t>Why the local-cache counterexample was the bug</a:t>
             </a:r>
           </a:p>
           <a:p>
@@ -24107,7 +24107,7 @@
                 </a:solidFill>
                 <a:latin typeface="Calibri"/>
               </a:rPr>
-              <a:t>Doc 08</a:t>
+              <a:t>§8</a:t>
             </a:r>
           </a:p>
         </p:txBody>
@@ -24523,7 +24523,7 @@
                 </a:solidFill>
                 <a:latin typeface="Calibri"/>
               </a:rPr>
-              <a:t>Doc 08</a:t>
+              <a:t>§8</a:t>
             </a:r>
           </a:p>
         </p:txBody>
@@ -24931,7 +24931,7 @@
                 </a:solidFill>
                 <a:latin typeface="Calibri"/>
               </a:rPr>
-              <a:t>Doc 08</a:t>
+              <a:t>§8</a:t>
             </a:r>
           </a:p>
         </p:txBody>
@@ -25813,7 +25813,7 @@
                 </a:solidFill>
                 <a:latin typeface="Calibri"/>
               </a:rPr>
-              <a:t>Doc 01</a:t>
+              <a:t>§1</a:t>
             </a:r>
           </a:p>
         </p:txBody>
@@ -26229,7 +26229,7 @@
                 </a:solidFill>
                 <a:latin typeface="Calibri"/>
               </a:rPr>
-              <a:t>Doc 09</a:t>
+              <a:t>§9</a:t>
             </a:r>
           </a:p>
         </p:txBody>
@@ -26645,7 +26645,7 @@
                 </a:solidFill>
                 <a:latin typeface="Calibri"/>
               </a:rPr>
-              <a:t>Doc 09</a:t>
+              <a:t>§9</a:t>
             </a:r>
           </a:p>
         </p:txBody>
@@ -26869,7 +26869,7 @@
                 </a:solidFill>
                 <a:latin typeface="Calibri"/>
               </a:rPr>
-              <a:t>•  std::stop_token cancels background workers cleanly (Doc 5)</a:t>
+              <a:t>•  std::stop_token cancels background workers cleanly (the threading section)</a:t>
             </a:r>
           </a:p>
         </p:txBody>
@@ -27053,7 +27053,7 @@
                 </a:solidFill>
                 <a:latin typeface="Calibri"/>
               </a:rPr>
-              <a:t>Doc 09</a:t>
+              <a:t>§9</a:t>
             </a:r>
           </a:p>
         </p:txBody>
@@ -27445,7 +27445,7 @@
                 </a:solidFill>
                 <a:latin typeface="Calibri"/>
               </a:rPr>
-              <a:t>Doc 09</a:t>
+              <a:t>§9</a:t>
             </a:r>
           </a:p>
         </p:txBody>
@@ -28327,7 +28327,7 @@
                 </a:solidFill>
                 <a:latin typeface="Calibri"/>
               </a:rPr>
-              <a:t>Doc 10</a:t>
+              <a:t>§10</a:t>
             </a:r>
           </a:p>
         </p:txBody>
@@ -28471,7 +28471,7 @@
                 </a:solidFill>
                 <a:latin typeface="Calibri"/>
               </a:rPr>
-              <a:t>Every prior doc, in one main()</a:t>
+              <a:t>Every prior section, in one main()</a:t>
             </a:r>
           </a:p>
           <a:p>
@@ -28487,7 +28487,7 @@
                 </a:solidFill>
                 <a:latin typeface="Calibri"/>
               </a:rPr>
-              <a:t>•  Config parsed once (Doc 6); process-scoped pool + channel cache (Doc 4)</a:t>
+              <a:t>•  Config parsed once (12-factor config); process-scoped pool + channel cache (process scope)</a:t>
             </a:r>
           </a:p>
           <a:p>
@@ -28503,7 +28503,7 @@
                 </a:solidFill>
                 <a:latin typeface="Calibri"/>
               </a:rPr>
-              <a:t>•  RequestContext with a PMR arena per call (Docs 2, 3)</a:t>
+              <a:t>•  RequestContext with a PMR arena per call (RAII + PMR)</a:t>
             </a:r>
           </a:p>
           <a:p>
@@ -28519,7 +28519,7 @@
                 </a:solidFill>
                 <a:latin typeface="Calibri"/>
               </a:rPr>
-              <a:t>•  Handler throws grpc::Status; RAII cleans up; boundary translates (Doc 2)</a:t>
+              <a:t>•  Handler throws grpc::Status; RAII cleans up; boundary translates (the RAII section)</a:t>
             </a:r>
           </a:p>
           <a:p>
@@ -28535,7 +28535,7 @@
                 </a:solidFill>
                 <a:latin typeface="Calibri"/>
               </a:rPr>
-              <a:t>•  Deadline-propagated PostgreSQL + outbound gRPC tax call (Docs 5, 7)</a:t>
+              <a:t>•  Deadline-propagated PostgreSQL + outbound gRPC tax call (threading + externalization)</a:t>
             </a:r>
           </a:p>
           <a:p>
@@ -28551,7 +28551,7 @@
                 </a:solidFill>
                 <a:latin typeface="Calibri"/>
               </a:rPr>
-              <a:t>•  Idempotency on the client key; staged health + graceful shutdown (Docs 7, 9)</a:t>
+              <a:t>•  Idempotency on the client key; staged health + graceful shutdown (externalization + health)</a:t>
             </a:r>
           </a:p>
         </p:txBody>
@@ -28759,7 +28759,7 @@
                 </a:solidFill>
                 <a:latin typeface="Calibri"/>
               </a:rPr>
-              <a:t>Doc 10</a:t>
+              <a:t>§10</a:t>
             </a:r>
           </a:p>
         </p:txBody>
@@ -29167,7 +29167,7 @@
                 </a:solidFill>
                 <a:latin typeface="Calibri"/>
               </a:rPr>
-              <a:t>Doc 10</a:t>
+              <a:t>§10</a:t>
             </a:r>
           </a:p>
         </p:txBody>
@@ -29757,7 +29757,7 @@
                 </a:solidFill>
                 <a:latin typeface="Calibri"/>
               </a:rPr>
-              <a:t>Doc 10</a:t>
+              <a:t>§10</a:t>
             </a:r>
           </a:p>
         </p:txBody>
@@ -30149,7 +30149,7 @@
                 </a:solidFill>
                 <a:latin typeface="Calibri"/>
               </a:rPr>
-              <a:t>Doc 01</a:t>
+              <a:t>§1</a:t>
             </a:r>
           </a:p>
         </p:txBody>
@@ -30341,7 +30341,7 @@
                 </a:solidFill>
                 <a:latin typeface="Calibri"/>
               </a:rPr>
-              <a:t>•  "The filesystem persists" — the rootfs is ephemeral (Doc 8)</a:t>
+              <a:t>•  "The filesystem persists" — the rootfs is ephemeral (ephemeral filesystem)</a:t>
             </a:r>
           </a:p>
           <a:p>
@@ -30357,7 +30357,7 @@
                 </a:solidFill>
                 <a:latin typeface="Calibri"/>
               </a:rPr>
-              <a:t>•  "My thread pool should match the CPU count" — it should match the cgroup (Doc 5)</a:t>
+              <a:t>•  "My thread pool should match the CPU count" — it should match the cgroup (threading)</a:t>
             </a:r>
           </a:p>
           <a:p>
@@ -30373,7 +30373,7 @@
                 </a:solidFill>
                 <a:latin typeface="Calibri"/>
               </a:rPr>
-              <a:t>•  "Local cache is free" — it desyncs across replicas (Doc 7)</a:t>
+              <a:t>•  "Local cache is free" — it desyncs across replicas (state externalization)</a:t>
             </a:r>
           </a:p>
           <a:p>
@@ -30389,7 +30389,7 @@
                 </a:solidFill>
                 <a:latin typeface="Calibri"/>
               </a:rPr>
-              <a:t>•  "Restart is exceptional" — under orchestration it's routine (Doc 9)</a:t>
+              <a:t>•  "Restart is exceptional" — under orchestration it's routine (health &amp; shutdown)</a:t>
             </a:r>
           </a:p>
         </p:txBody>
@@ -31063,7 +31063,7 @@
                 </a:solidFill>
                 <a:latin typeface="Calibri"/>
               </a:rPr>
-              <a:t>Doc 11</a:t>
+              <a:t>§11</a:t>
             </a:r>
           </a:p>
         </p:txBody>
@@ -31287,7 +31287,7 @@
                 </a:solidFill>
                 <a:latin typeface="Calibri"/>
               </a:rPr>
-              <a:t>•  Dev profile wires AddressSanitizer — catches the Doc 3 arena trap early</a:t>
+              <a:t>•  Dev profile wires AddressSanitizer — catches the PMR arena trap early</a:t>
             </a:r>
           </a:p>
         </p:txBody>
@@ -31495,7 +31495,7 @@
                 </a:solidFill>
                 <a:latin typeface="Calibri"/>
               </a:rPr>
-              <a:t>Doc 11</a:t>
+              <a:t>§11</a:t>
             </a:r>
           </a:p>
         </p:txBody>
@@ -31887,7 +31887,7 @@
                 </a:solidFill>
                 <a:latin typeface="Calibri"/>
               </a:rPr>
-              <a:t>Doc 11</a:t>
+              <a:t>§11</a:t>
             </a:r>
           </a:p>
         </p:txBody>
@@ -32295,7 +32295,7 @@
                 </a:solidFill>
                 <a:latin typeface="Calibri"/>
               </a:rPr>
-              <a:t>Doc 11</a:t>
+              <a:t>§11</a:t>
             </a:r>
           </a:p>
         </p:txBody>
@@ -33219,7 +33219,7 @@
                 </a:solidFill>
                 <a:latin typeface="Calibri"/>
               </a:rPr>
-              <a:t>Doc 01</a:t>
+              <a:t>§1</a:t>
             </a:r>
           </a:p>
         </p:txBody>
@@ -33809,7 +33809,7 @@
                 </a:solidFill>
                 <a:latin typeface="Calibri"/>
               </a:rPr>
-              <a:t>Doc 02</a:t>
+              <a:t>§2</a:t>
             </a:r>
           </a:p>
         </p:txBody>

</xml_diff>